<commit_message>
Downloads M05-M21 neu erzeugt nach Quellmodul-Normalisierung
Teilnehmer-PDFs, Trainerhandbuecher und Praesentationen mit saubereren
Deckblaettern (YAML-Frontmatter jetzt in allen Quellen vorhanden).

Co-Authored-By: Claude Opus 4 <noreply@anthropic.com>
</commit_message>
<xml_diff>
--- a/public/downloads/praesentation/M06.pptx
+++ b/public/downloads/praesentation/M06.pptx
@@ -3254,7 +3254,42 @@
       </p:sp>
       <p:sp>
         <p:nvSpPr>
-          <p:cNvPr id="6" name="Rectangle 5"/>
+          <p:cNvPr id="6" name="TextBox 5"/>
+          <p:cNvSpPr txBox="1"/>
+          <p:nvPr/>
+        </p:nvSpPr>
+        <p:spPr>
+          <a:xfrm>
+            <a:off x="685800" y="3977639"/>
+            <a:ext cx="10817352" cy="731520"/>
+          </a:xfrm>
+          <a:prstGeom prst="rect">
+            <a:avLst/>
+          </a:prstGeom>
+          <a:noFill/>
+        </p:spPr>
+        <p:txBody>
+          <a:bodyPr wrap="square">
+            <a:spAutoFit/>
+          </a:bodyPr>
+          <a:lstStyle/>
+          <a:p>
+            <a:pPr algn="l"/>
+            <a:r>
+              <a:rPr sz="1900" b="0" i="1">
+                <a:solidFill>
+                  <a:srgbClr val="BECDE6"/>
+                </a:solidFill>
+                <a:latin typeface="Source Serif 4"/>
+              </a:rPr>
+              <a:t>Branchenwissen für den Firmenkundenberater</a:t>
+            </a:r>
+          </a:p>
+        </p:txBody>
+      </p:sp>
+      <p:sp>
+        <p:nvSpPr>
+          <p:cNvPr id="7" name="Rectangle 6"/>
           <p:cNvSpPr/>
           <p:nvPr/>
         </p:nvSpPr>
@@ -3297,14 +3332,14 @@
       </p:sp>
       <p:sp>
         <p:nvSpPr>
-          <p:cNvPr id="7" name="TextBox 6"/>
+          <p:cNvPr id="8" name="TextBox 7"/>
           <p:cNvSpPr txBox="1"/>
           <p:nvPr/>
         </p:nvSpPr>
         <p:spPr>
           <a:xfrm>
             <a:off x="685800" y="5193792"/>
-            <a:ext cx="5408676" cy="201168"/>
+            <a:ext cx="3605784" cy="201168"/>
           </a:xfrm>
           <a:prstGeom prst="rect">
             <a:avLst/>
@@ -3332,14 +3367,14 @@
       </p:sp>
       <p:sp>
         <p:nvSpPr>
-          <p:cNvPr id="8" name="TextBox 7"/>
+          <p:cNvPr id="9" name="TextBox 8"/>
           <p:cNvSpPr txBox="1"/>
           <p:nvPr/>
         </p:nvSpPr>
         <p:spPr>
           <a:xfrm>
             <a:off x="685800" y="5394960"/>
-            <a:ext cx="5408676" cy="320040"/>
+            <a:ext cx="3605784" cy="320040"/>
           </a:xfrm>
           <a:prstGeom prst="rect">
             <a:avLst/>
@@ -3367,14 +3402,14 @@
       </p:sp>
       <p:sp>
         <p:nvSpPr>
-          <p:cNvPr id="9" name="TextBox 8"/>
+          <p:cNvPr id="10" name="TextBox 9"/>
           <p:cNvSpPr txBox="1"/>
           <p:nvPr/>
         </p:nvSpPr>
         <p:spPr>
           <a:xfrm>
-            <a:off x="6094476" y="5193792"/>
-            <a:ext cx="5408676" cy="201168"/>
+            <a:off x="4291584" y="5193792"/>
+            <a:ext cx="3605784" cy="201168"/>
           </a:xfrm>
           <a:prstGeom prst="rect">
             <a:avLst/>
@@ -3395,21 +3430,21 @@
                 </a:solidFill>
                 <a:latin typeface="JetBrains Mono"/>
               </a:rPr>
-              <a:t>VERSION</a:t>
-            </a:r>
-          </a:p>
-        </p:txBody>
-      </p:sp>
-      <p:sp>
-        <p:nvSpPr>
-          <p:cNvPr id="10" name="TextBox 9"/>
+              <a:t>KOMPETENZSTUFE</a:t>
+            </a:r>
+          </a:p>
+        </p:txBody>
+      </p:sp>
+      <p:sp>
+        <p:nvSpPr>
+          <p:cNvPr id="11" name="TextBox 10"/>
           <p:cNvSpPr txBox="1"/>
           <p:nvPr/>
         </p:nvSpPr>
         <p:spPr>
           <a:xfrm>
-            <a:off x="6094476" y="5394960"/>
-            <a:ext cx="5408676" cy="320040"/>
+            <a:off x="4291584" y="5394960"/>
+            <a:ext cx="3605784" cy="320040"/>
           </a:xfrm>
           <a:prstGeom prst="rect">
             <a:avLst/>
@@ -3430,6 +3465,76 @@
                 </a:solidFill>
                 <a:latin typeface="Arial"/>
               </a:rPr>
+              <a:t>Berater</a:t>
+            </a:r>
+          </a:p>
+        </p:txBody>
+      </p:sp>
+      <p:sp>
+        <p:nvSpPr>
+          <p:cNvPr id="12" name="TextBox 11"/>
+          <p:cNvSpPr txBox="1"/>
+          <p:nvPr/>
+        </p:nvSpPr>
+        <p:spPr>
+          <a:xfrm>
+            <a:off x="7897368" y="5193792"/>
+            <a:ext cx="3605784" cy="201168"/>
+          </a:xfrm>
+          <a:prstGeom prst="rect">
+            <a:avLst/>
+          </a:prstGeom>
+          <a:noFill/>
+        </p:spPr>
+        <p:txBody>
+          <a:bodyPr wrap="none">
+            <a:spAutoFit/>
+          </a:bodyPr>
+          <a:lstStyle/>
+          <a:p>
+            <a:pPr algn="l"/>
+            <a:r>
+              <a:rPr sz="700">
+                <a:solidFill>
+                  <a:srgbClr val="A0B4D2"/>
+                </a:solidFill>
+                <a:latin typeface="JetBrains Mono"/>
+              </a:rPr>
+              <a:t>VERSION</a:t>
+            </a:r>
+          </a:p>
+        </p:txBody>
+      </p:sp>
+      <p:sp>
+        <p:nvSpPr>
+          <p:cNvPr id="13" name="TextBox 12"/>
+          <p:cNvSpPr txBox="1"/>
+          <p:nvPr/>
+        </p:nvSpPr>
+        <p:spPr>
+          <a:xfrm>
+            <a:off x="7897368" y="5394960"/>
+            <a:ext cx="3605784" cy="320040"/>
+          </a:xfrm>
+          <a:prstGeom prst="rect">
+            <a:avLst/>
+          </a:prstGeom>
+          <a:noFill/>
+        </p:spPr>
+        <p:txBody>
+          <a:bodyPr wrap="square">
+            <a:spAutoFit/>
+          </a:bodyPr>
+          <a:lstStyle/>
+          <a:p>
+            <a:pPr algn="l"/>
+            <a:r>
+              <a:rPr sz="1100" b="0" i="0">
+                <a:solidFill>
+                  <a:srgbClr val="FFFFFF"/>
+                </a:solidFill>
+                <a:latin typeface="Arial"/>
+              </a:rPr>
               <a:t>v0.4</a:t>
             </a:r>
           </a:p>
@@ -3437,7 +3542,7 @@
       </p:sp>
       <p:sp>
         <p:nvSpPr>
-          <p:cNvPr id="11" name="Rectangle 10"/>
+          <p:cNvPr id="14" name="Rectangle 13"/>
           <p:cNvSpPr/>
           <p:nvPr/>
         </p:nvSpPr>
@@ -3480,7 +3585,7 @@
       </p:sp>
       <p:sp>
         <p:nvSpPr>
-          <p:cNvPr id="12" name="TextBox 11"/>
+          <p:cNvPr id="15" name="TextBox 14"/>
           <p:cNvSpPr txBox="1"/>
           <p:nvPr/>
         </p:nvSpPr>
@@ -3515,7 +3620,7 @@
       </p:sp>
       <p:sp>
         <p:nvSpPr>
-          <p:cNvPr id="13" name="TextBox 12"/>
+          <p:cNvPr id="16" name="TextBox 15"/>
           <p:cNvSpPr txBox="1"/>
           <p:nvPr/>
         </p:nvSpPr>

</xml_diff>